<commit_message>
Slide più leggibili: codice più grande, espressioni for, schema della rete; dispensa 0 rinominata
</commit_message>
<xml_diff>
--- a/slide/slide-0-terraform.pptx
+++ b/slide/slide-0-terraform.pptx
@@ -2556,7 +2556,7 @@
                 <a:ea typeface="Calibri" pitchFamily="34" charset="-122"/>
                 <a:cs typeface="Calibri" pitchFamily="34" charset="-120"/>
               </a:rPr>
-              <a:t>Dispensa 0 · Terraform in 20 minuti</a:t>
+              <a:t>Dispensa 0 · Terraform: le basi</a:t>
             </a:r>
             <a:endParaRPr lang="en-US" sz="1600" dirty="0"/>
           </a:p>
@@ -2595,7 +2595,7 @@
                 <a:ea typeface="Calibri" pitchFamily="34" charset="-122"/>
                 <a:cs typeface="Calibri" pitchFamily="34" charset="-120"/>
               </a:rPr>
-              <a:t>Terraform in 20 minuti</a:t>
+              <a:t>Terraform: le basi</a:t>
             </a:r>
             <a:endParaRPr lang="en-US" sz="4800" dirty="0"/>
           </a:p>
@@ -2783,7 +2783,7 @@
                 <a:ea typeface="Calibri" pitchFamily="34" charset="-122"/>
                 <a:cs typeface="Calibri" pitchFamily="34" charset="-120"/>
               </a:rPr>
-              <a:t>Dispensa 0 · Terraform in 20 minuti</a:t>
+              <a:t>Dispensa 0 · Terraform: le basi</a:t>
             </a:r>
             <a:endParaRPr lang="en-US" sz="1000" dirty="0"/>
           </a:p>
@@ -3922,7 +3922,7 @@
                 <a:ea typeface="Calibri" pitchFamily="34" charset="-122"/>
                 <a:cs typeface="Calibri" pitchFamily="34" charset="-120"/>
               </a:rPr>
-              <a:t>Dispensa 0 · Terraform in 20 minuti</a:t>
+              <a:t>Dispensa 0 · Terraform: le basi</a:t>
             </a:r>
             <a:endParaRPr lang="en-US" sz="1000" dirty="0"/>
           </a:p>
@@ -4384,7 +4384,7 @@
               <a:buNone/>
             </a:pPr>
             <a:r>
-              <a:rPr lang="en-US" sz="1500" dirty="0">
+              <a:rPr lang="en-US" sz="1600" dirty="0">
                 <a:solidFill>
                   <a:srgbClr val="8FD694"/>
                 </a:solidFill>
@@ -4394,14 +4394,14 @@
               </a:rPr>
               <a:t># variables.tf: il campo vuoto</a:t>
             </a:r>
-            <a:endParaRPr lang="en-US" sz="1500" dirty="0"/>
+            <a:endParaRPr lang="en-US" sz="1600" dirty="0"/>
           </a:p>
           <a:p>
             <a:pPr indent="0" marL="0">
               <a:buNone/>
             </a:pPr>
             <a:r>
-              <a:rPr lang="en-US" sz="1500" dirty="0">
+              <a:rPr lang="en-US" sz="1600" dirty="0">
                 <a:solidFill>
                   <a:srgbClr val="E6E6F0"/>
                 </a:solidFill>
@@ -4411,14 +4411,14 @@
               </a:rPr>
               <a:t>variable "project" {</a:t>
             </a:r>
-            <a:endParaRPr lang="en-US" sz="1500" dirty="0"/>
+            <a:endParaRPr lang="en-US" sz="1600" dirty="0"/>
           </a:p>
           <a:p>
             <a:pPr indent="0" marL="0">
               <a:buNone/>
             </a:pPr>
             <a:r>
-              <a:rPr lang="en-US" sz="1500" dirty="0">
+              <a:rPr lang="en-US" sz="1600" dirty="0">
                 <a:solidFill>
                   <a:srgbClr val="E6E6F0"/>
                 </a:solidFill>
@@ -4428,14 +4428,14 @@
               </a:rPr>
               <a:t>  type        = string</a:t>
             </a:r>
-            <a:endParaRPr lang="en-US" sz="1500" dirty="0"/>
+            <a:endParaRPr lang="en-US" sz="1600" dirty="0"/>
           </a:p>
           <a:p>
             <a:pPr indent="0" marL="0">
               <a:buNone/>
             </a:pPr>
             <a:r>
-              <a:rPr lang="en-US" sz="1500" dirty="0">
+              <a:rPr lang="en-US" sz="1600" dirty="0">
                 <a:solidFill>
                   <a:srgbClr val="E6E6F0"/>
                 </a:solidFill>
@@ -4445,14 +4445,14 @@
               </a:rPr>
               <a:t>  description = "Prefisso dei nomi"</a:t>
             </a:r>
-            <a:endParaRPr lang="en-US" sz="1500" dirty="0"/>
+            <a:endParaRPr lang="en-US" sz="1600" dirty="0"/>
           </a:p>
           <a:p>
             <a:pPr indent="0" marL="0">
               <a:buNone/>
             </a:pPr>
             <a:r>
-              <a:rPr lang="en-US" sz="1500" dirty="0">
+              <a:rPr lang="en-US" sz="1600" dirty="0">
                 <a:solidFill>
                   <a:srgbClr val="E6E6F0"/>
                 </a:solidFill>
@@ -4462,7 +4462,7 @@
               </a:rPr>
               <a:t>}</a:t>
             </a:r>
-            <a:endParaRPr lang="en-US" sz="1500" dirty="0"/>
+            <a:endParaRPr lang="en-US" sz="1600" dirty="0"/>
           </a:p>
         </p:txBody>
       </p:sp>
@@ -4518,7 +4518,7 @@
               <a:buNone/>
             </a:pPr>
             <a:r>
-              <a:rPr lang="en-US" sz="1500" dirty="0">
+              <a:rPr lang="en-US" sz="1600" dirty="0">
                 <a:solidFill>
                   <a:srgbClr val="8FD694"/>
                 </a:solidFill>
@@ -4528,14 +4528,14 @@
               </a:rPr>
               <a:t># terraform.tfvars: il campo compilato</a:t>
             </a:r>
-            <a:endParaRPr lang="en-US" sz="1500" dirty="0"/>
+            <a:endParaRPr lang="en-US" sz="1600" dirty="0"/>
           </a:p>
           <a:p>
             <a:pPr indent="0" marL="0">
               <a:buNone/>
             </a:pPr>
             <a:r>
-              <a:rPr lang="en-US" sz="1500" dirty="0">
+              <a:rPr lang="en-US" sz="1600" dirty="0">
                 <a:solidFill>
                   <a:srgbClr val="E6E6F0"/>
                 </a:solidFill>
@@ -4545,7 +4545,7 @@
               </a:rPr>
               <a:t>project = "corso-aws"</a:t>
             </a:r>
-            <a:endParaRPr lang="en-US" sz="1500" dirty="0"/>
+            <a:endParaRPr lang="en-US" sz="1600" dirty="0"/>
           </a:p>
         </p:txBody>
       </p:sp>
@@ -4767,7 +4767,7 @@
                 <a:ea typeface="Calibri" pitchFamily="34" charset="-122"/>
                 <a:cs typeface="Calibri" pitchFamily="34" charset="-120"/>
               </a:rPr>
-              <a:t>Dispensa 0 · Terraform in 20 minuti</a:t>
+              <a:t>Dispensa 0 · Terraform: le basi</a:t>
             </a:r>
             <a:endParaRPr lang="en-US" sz="1000" dirty="0"/>
           </a:p>
@@ -5571,7 +5571,7 @@
                 <a:ea typeface="Calibri" pitchFamily="34" charset="-122"/>
                 <a:cs typeface="Calibri" pitchFamily="34" charset="-120"/>
               </a:rPr>
-              <a:t>Dispensa 0 · Terraform in 20 minuti</a:t>
+              <a:t>Dispensa 0 · Terraform: le basi</a:t>
             </a:r>
             <a:endParaRPr lang="en-US" sz="1000" dirty="0"/>
           </a:p>
@@ -6281,7 +6281,7 @@
                 <a:ea typeface="Calibri" pitchFamily="34" charset="-122"/>
                 <a:cs typeface="Calibri" pitchFamily="34" charset="-120"/>
               </a:rPr>
-              <a:t>Dispensa 0 · Terraform in 20 minuti</a:t>
+              <a:t>Dispensa 0 · Terraform: le basi</a:t>
             </a:r>
             <a:endParaRPr lang="en-US" sz="1000" dirty="0"/>
           </a:p>
@@ -7263,7 +7263,7 @@
                 <a:ea typeface="Calibri" pitchFamily="34" charset="-122"/>
                 <a:cs typeface="Calibri" pitchFamily="34" charset="-120"/>
               </a:rPr>
-              <a:t>Dispensa 0 · Terraform in 20 minuti</a:t>
+              <a:t>Dispensa 0 · Terraform: le basi</a:t>
             </a:r>
             <a:endParaRPr lang="en-US" sz="1000" dirty="0"/>
           </a:p>
@@ -7678,7 +7678,7 @@
               <a:buNone/>
             </a:pPr>
             <a:r>
-              <a:rPr lang="en-US" sz="1400" dirty="0">
+              <a:rPr lang="en-US" sz="1600" dirty="0">
                 <a:solidFill>
                   <a:srgbClr val="E6E6F0"/>
                 </a:solidFill>
@@ -7688,14 +7688,14 @@
               </a:rPr>
               <a:t>terraform {</a:t>
             </a:r>
-            <a:endParaRPr lang="en-US" sz="1400" dirty="0"/>
+            <a:endParaRPr lang="en-US" sz="1600" dirty="0"/>
           </a:p>
           <a:p>
             <a:pPr indent="0" marL="0">
               <a:buNone/>
             </a:pPr>
             <a:r>
-              <a:rPr lang="en-US" sz="1400" dirty="0">
+              <a:rPr lang="en-US" sz="1600" dirty="0">
                 <a:solidFill>
                   <a:srgbClr val="E6E6F0"/>
                 </a:solidFill>
@@ -7705,14 +7705,14 @@
               </a:rPr>
               <a:t>  backend "s3" {</a:t>
             </a:r>
-            <a:endParaRPr lang="en-US" sz="1400" dirty="0"/>
+            <a:endParaRPr lang="en-US" sz="1600" dirty="0"/>
           </a:p>
           <a:p>
             <a:pPr indent="0" marL="0">
               <a:buNone/>
             </a:pPr>
             <a:r>
-              <a:rPr lang="en-US" sz="1400" dirty="0">
+              <a:rPr lang="en-US" sz="1600" dirty="0">
                 <a:solidFill>
                   <a:srgbClr val="E6E6F0"/>
                 </a:solidFill>
@@ -7722,14 +7722,14 @@
               </a:rPr>
               <a:t>    bucket       = "corso-aws-tfstate-&lt;account&gt;"</a:t>
             </a:r>
-            <a:endParaRPr lang="en-US" sz="1400" dirty="0"/>
+            <a:endParaRPr lang="en-US" sz="1600" dirty="0"/>
           </a:p>
           <a:p>
             <a:pPr indent="0" marL="0">
               <a:buNone/>
             </a:pPr>
             <a:r>
-              <a:rPr lang="en-US" sz="1400" dirty="0">
+              <a:rPr lang="en-US" sz="1600" dirty="0">
                 <a:solidFill>
                   <a:srgbClr val="E6E6F0"/>
                 </a:solidFill>
@@ -7739,14 +7739,14 @@
               </a:rPr>
               <a:t>    key          = "corso/terraform.tfstate"</a:t>
             </a:r>
-            <a:endParaRPr lang="en-US" sz="1400" dirty="0"/>
+            <a:endParaRPr lang="en-US" sz="1600" dirty="0"/>
           </a:p>
           <a:p>
             <a:pPr indent="0" marL="0">
               <a:buNone/>
             </a:pPr>
             <a:r>
-              <a:rPr lang="en-US" sz="1400" dirty="0">
+              <a:rPr lang="en-US" sz="1600" dirty="0">
                 <a:solidFill>
                   <a:srgbClr val="E6E6F0"/>
                 </a:solidFill>
@@ -7756,14 +7756,14 @@
               </a:rPr>
               <a:t>    region       = "eu-south-1"</a:t>
             </a:r>
-            <a:endParaRPr lang="en-US" sz="1400" dirty="0"/>
+            <a:endParaRPr lang="en-US" sz="1600" dirty="0"/>
           </a:p>
           <a:p>
             <a:pPr indent="0" marL="0">
               <a:buNone/>
             </a:pPr>
             <a:r>
-              <a:rPr lang="en-US" sz="1400" dirty="0">
+              <a:rPr lang="en-US" sz="1600" dirty="0">
                 <a:solidFill>
                   <a:srgbClr val="E6E6F0"/>
                 </a:solidFill>
@@ -7777,7 +7777,7 @@
               <a:buNone/>
             </a:pPr>
             <a:r>
-              <a:rPr lang="en-US" sz="1400" dirty="0">
+              <a:rPr lang="en-US" sz="1600" dirty="0">
                 <a:solidFill>
                   <a:srgbClr val="8FD694"/>
                 </a:solidFill>
@@ -7787,14 +7787,14 @@
               </a:rPr>
               <a:t># state cifrato</a:t>
             </a:r>
-            <a:endParaRPr lang="en-US" sz="1400" dirty="0"/>
+            <a:endParaRPr lang="en-US" sz="1600" dirty="0"/>
           </a:p>
           <a:p>
             <a:pPr indent="0" marL="0">
               <a:buNone/>
             </a:pPr>
             <a:r>
-              <a:rPr lang="en-US" sz="1400" dirty="0">
+              <a:rPr lang="en-US" sz="1600" dirty="0">
                 <a:solidFill>
                   <a:srgbClr val="E6E6F0"/>
                 </a:solidFill>
@@ -7808,7 +7808,7 @@
               <a:buNone/>
             </a:pPr>
             <a:r>
-              <a:rPr lang="en-US" sz="1400" dirty="0">
+              <a:rPr lang="en-US" sz="1600" dirty="0">
                 <a:solidFill>
                   <a:srgbClr val="8FD694"/>
                 </a:solidFill>
@@ -7818,14 +7818,14 @@
               </a:rPr>
               <a:t># lock su S3</a:t>
             </a:r>
-            <a:endParaRPr lang="en-US" sz="1400" dirty="0"/>
+            <a:endParaRPr lang="en-US" sz="1600" dirty="0"/>
           </a:p>
           <a:p>
             <a:pPr indent="0" marL="0">
               <a:buNone/>
             </a:pPr>
             <a:r>
-              <a:rPr lang="en-US" sz="1400" dirty="0">
+              <a:rPr lang="en-US" sz="1600" dirty="0">
                 <a:solidFill>
                   <a:srgbClr val="E6E6F0"/>
                 </a:solidFill>
@@ -7835,14 +7835,14 @@
               </a:rPr>
               <a:t>  }</a:t>
             </a:r>
-            <a:endParaRPr lang="en-US" sz="1400" dirty="0"/>
+            <a:endParaRPr lang="en-US" sz="1600" dirty="0"/>
           </a:p>
           <a:p>
             <a:pPr indent="0" marL="0">
               <a:buNone/>
             </a:pPr>
             <a:r>
-              <a:rPr lang="en-US" sz="1400" dirty="0">
+              <a:rPr lang="en-US" sz="1600" dirty="0">
                 <a:solidFill>
                   <a:srgbClr val="E6E6F0"/>
                 </a:solidFill>
@@ -7852,7 +7852,7 @@
               </a:rPr>
               <a:t>}</a:t>
             </a:r>
-            <a:endParaRPr lang="en-US" sz="1400" dirty="0"/>
+            <a:endParaRPr lang="en-US" sz="1600" dirty="0"/>
           </a:p>
         </p:txBody>
       </p:sp>
@@ -8008,7 +8008,7 @@
                 <a:ea typeface="Calibri" pitchFamily="34" charset="-122"/>
                 <a:cs typeface="Calibri" pitchFamily="34" charset="-120"/>
               </a:rPr>
-              <a:t>Dispensa 0 · Terraform in 20 minuti</a:t>
+              <a:t>Dispensa 0 · Terraform: le basi</a:t>
             </a:r>
             <a:endParaRPr lang="en-US" sz="1000" dirty="0"/>
           </a:p>
@@ -8909,7 +8909,7 @@
                 <a:ea typeface="Calibri" pitchFamily="34" charset="-122"/>
                 <a:cs typeface="Calibri" pitchFamily="34" charset="-120"/>
               </a:rPr>
-              <a:t>Dispensa 0 · Terraform in 20 minuti</a:t>
+              <a:t>Dispensa 0 · Terraform: le basi</a:t>
             </a:r>
             <a:endParaRPr lang="en-US" sz="1000" dirty="0"/>
           </a:p>
@@ -10391,7 +10391,7 @@
                 <a:ea typeface="Calibri" pitchFamily="34" charset="-122"/>
                 <a:cs typeface="Calibri" pitchFamily="34" charset="-120"/>
               </a:rPr>
-              <a:t>Dispensa 0 · Terraform in 20 minuti</a:t>
+              <a:t>Dispensa 0 · Terraform: le basi</a:t>
             </a:r>
             <a:endParaRPr lang="en-US" sz="1000" dirty="0"/>
           </a:p>
@@ -11177,7 +11177,7 @@
                 <a:ea typeface="Calibri" pitchFamily="34" charset="-122"/>
                 <a:cs typeface="Calibri" pitchFamily="34" charset="-120"/>
               </a:rPr>
-              <a:t>Dispensa 0 · Terraform in 20 minuti</a:t>
+              <a:t>Dispensa 0 · Terraform: le basi</a:t>
             </a:r>
             <a:endParaRPr lang="en-US" sz="1000" dirty="0"/>
           </a:p>
@@ -11843,7 +11843,7 @@
                 <a:ea typeface="Calibri" pitchFamily="34" charset="-122"/>
                 <a:cs typeface="Calibri" pitchFamily="34" charset="-120"/>
               </a:rPr>
-              <a:t>Dispensa 0 · Terraform in 20 minuti</a:t>
+              <a:t>Dispensa 0 · Terraform: le basi</a:t>
             </a:r>
             <a:endParaRPr lang="en-US" sz="1000" dirty="0"/>
           </a:p>
@@ -12445,7 +12445,7 @@
                 <a:ea typeface="Calibri" pitchFamily="34" charset="-122"/>
                 <a:cs typeface="Calibri" pitchFamily="34" charset="-120"/>
               </a:rPr>
-              <a:t>Dispensa 0 · Terraform in 20 minuti</a:t>
+              <a:t>Dispensa 0 · Terraform: le basi</a:t>
             </a:r>
             <a:endParaRPr lang="en-US" sz="1000" dirty="0"/>
           </a:p>
@@ -13319,7 +13319,7 @@
                 <a:ea typeface="Calibri" pitchFamily="34" charset="-122"/>
                 <a:cs typeface="Calibri" pitchFamily="34" charset="-120"/>
               </a:rPr>
-              <a:t>Dispensa 0 · Terraform in 20 minuti</a:t>
+              <a:t>Dispensa 0 · Terraform: le basi</a:t>
             </a:r>
             <a:endParaRPr lang="en-US" sz="1000" dirty="0"/>
           </a:p>
@@ -13940,7 +13940,7 @@
                 <a:ea typeface="Calibri" pitchFamily="34" charset="-122"/>
                 <a:cs typeface="Calibri" pitchFamily="34" charset="-120"/>
               </a:rPr>
-              <a:t>Dispensa 0 · Terraform in 20 minuti</a:t>
+              <a:t>Dispensa 0 · Terraform: le basi</a:t>
             </a:r>
             <a:endParaRPr lang="en-US" sz="1000" dirty="0"/>
           </a:p>
@@ -15571,7 +15571,7 @@
                 <a:ea typeface="Calibri" pitchFamily="34" charset="-122"/>
                 <a:cs typeface="Calibri" pitchFamily="34" charset="-120"/>
               </a:rPr>
-              <a:t>Dispensa 0 · Terraform in 20 minuti</a:t>
+              <a:t>Dispensa 0 · Terraform: le basi</a:t>
             </a:r>
             <a:endParaRPr lang="en-US" sz="1000" dirty="0"/>
           </a:p>
@@ -15668,7 +15668,7 @@
               <a:buNone/>
             </a:pPr>
             <a:r>
-              <a:rPr lang="en-US" sz="1500" dirty="0">
+              <a:rPr lang="en-US" sz="1600" dirty="0">
                 <a:solidFill>
                   <a:srgbClr val="E6E6F0"/>
                 </a:solidFill>
@@ -15678,14 +15678,14 @@
               </a:rPr>
               <a:t>var.region</a:t>
             </a:r>
-            <a:endParaRPr lang="en-US" sz="1500" dirty="0"/>
+            <a:endParaRPr lang="en-US" sz="1600" dirty="0"/>
           </a:p>
           <a:p>
             <a:pPr indent="0" marL="0">
               <a:buNone/>
             </a:pPr>
             <a:r>
-              <a:rPr lang="en-US" sz="1500" dirty="0">
+              <a:rPr lang="en-US" sz="1600" dirty="0">
                 <a:solidFill>
                   <a:srgbClr val="E6E6F0"/>
                 </a:solidFill>
@@ -15695,14 +15695,14 @@
               </a:rPr>
               <a:t>local.name_prefix</a:t>
             </a:r>
-            <a:endParaRPr lang="en-US" sz="1500" dirty="0"/>
+            <a:endParaRPr lang="en-US" sz="1600" dirty="0"/>
           </a:p>
           <a:p>
             <a:pPr indent="0" marL="0">
               <a:buNone/>
             </a:pPr>
             <a:r>
-              <a:rPr lang="en-US" sz="1500" dirty="0">
+              <a:rPr lang="en-US" sz="1600" dirty="0">
                 <a:solidFill>
                   <a:srgbClr val="E6E6F0"/>
                 </a:solidFill>
@@ -15712,7 +15712,7 @@
               </a:rPr>
               <a:t>aws_s3_bucket.demo.arn</a:t>
             </a:r>
-            <a:endParaRPr lang="en-US" sz="1500" dirty="0"/>
+            <a:endParaRPr lang="en-US" sz="1600" dirty="0"/>
           </a:p>
         </p:txBody>
       </p:sp>
@@ -15807,7 +15807,7 @@
               <a:buNone/>
             </a:pPr>
             <a:r>
-              <a:rPr lang="en-US" sz="1500" dirty="0">
+              <a:rPr lang="en-US" sz="1600" dirty="0">
                 <a:solidFill>
                   <a:srgbClr val="E6E6F0"/>
                 </a:solidFill>
@@ -15817,14 +15817,14 @@
               </a:rPr>
               <a:t>"${var.project}-demo"</a:t>
             </a:r>
-            <a:endParaRPr lang="en-US" sz="1500" dirty="0"/>
+            <a:endParaRPr lang="en-US" sz="1600" dirty="0"/>
           </a:p>
           <a:p>
             <a:pPr indent="0" marL="0">
               <a:buNone/>
             </a:pPr>
             <a:r>
-              <a:rPr lang="en-US" sz="1500" dirty="0">
+              <a:rPr lang="en-US" sz="1600" dirty="0">
                 <a:solidFill>
                   <a:srgbClr val="8FD694"/>
                 </a:solidFill>
@@ -15834,7 +15834,7 @@
               </a:rPr>
               <a:t># → "corso-aws-demo"</a:t>
             </a:r>
-            <a:endParaRPr lang="en-US" sz="1500" dirty="0"/>
+            <a:endParaRPr lang="en-US" sz="1600" dirty="0"/>
           </a:p>
         </p:txBody>
       </p:sp>
@@ -15929,7 +15929,7 @@
               <a:buNone/>
             </a:pPr>
             <a:r>
-              <a:rPr lang="en-US" sz="1500" dirty="0">
+              <a:rPr lang="en-US" sz="1600" dirty="0">
                 <a:solidFill>
                   <a:srgbClr val="E6E6F0"/>
                 </a:solidFill>
@@ -15943,7 +15943,7 @@
               <a:buNone/>
             </a:pPr>
             <a:r>
-              <a:rPr lang="en-US" sz="1500" dirty="0">
+              <a:rPr lang="en-US" sz="1600" dirty="0">
                 <a:solidFill>
                   <a:srgbClr val="8FD694"/>
                 </a:solidFill>
@@ -15953,14 +15953,14 @@
               </a:rPr>
               <a:t># "CIAO"</a:t>
             </a:r>
-            <a:endParaRPr lang="en-US" sz="1500" dirty="0"/>
+            <a:endParaRPr lang="en-US" sz="1600" dirty="0"/>
           </a:p>
           <a:p>
             <a:pPr indent="0" marL="0">
               <a:buNone/>
             </a:pPr>
             <a:r>
-              <a:rPr lang="en-US" sz="1500" dirty="0">
+              <a:rPr lang="en-US" sz="1600" dirty="0">
                 <a:solidFill>
                   <a:srgbClr val="E6E6F0"/>
                 </a:solidFill>
@@ -15974,7 +15974,7 @@
               <a:buNone/>
             </a:pPr>
             <a:r>
-              <a:rPr lang="en-US" sz="1500" dirty="0">
+              <a:rPr lang="en-US" sz="1600" dirty="0">
                 <a:solidFill>
                   <a:srgbClr val="8FD694"/>
                 </a:solidFill>
@@ -15984,7 +15984,7 @@
               </a:rPr>
               <a:t># 2</a:t>
             </a:r>
-            <a:endParaRPr lang="en-US" sz="1500" dirty="0"/>
+            <a:endParaRPr lang="en-US" sz="1600" dirty="0"/>
           </a:p>
         </p:txBody>
       </p:sp>
@@ -16079,7 +16079,7 @@
               <a:buNone/>
             </a:pPr>
             <a:r>
-              <a:rPr lang="en-US" sz="1500" dirty="0">
+              <a:rPr lang="en-US" sz="1600" dirty="0">
                 <a:solidFill>
                   <a:srgbClr val="E6E6F0"/>
                 </a:solidFill>
@@ -16089,7 +16089,7 @@
               </a:rPr>
               <a:t>var.env == "prod" ? "grande" : "piccola"</a:t>
             </a:r>
-            <a:endParaRPr lang="en-US" sz="1500" dirty="0"/>
+            <a:endParaRPr lang="en-US" sz="1600" dirty="0"/>
           </a:p>
         </p:txBody>
       </p:sp>
@@ -16284,7 +16284,7 @@
                 <a:ea typeface="Calibri" pitchFamily="34" charset="-122"/>
                 <a:cs typeface="Calibri" pitchFamily="34" charset="-120"/>
               </a:rPr>
-              <a:t>Dispensa 0 · Terraform in 20 minuti</a:t>
+              <a:t>Dispensa 0 · Terraform: le basi</a:t>
             </a:r>
             <a:endParaRPr lang="en-US" sz="1000" dirty="0"/>
           </a:p>
@@ -16717,7 +16717,7 @@
               <a:buNone/>
             </a:pPr>
             <a:r>
-              <a:rPr lang="en-US" sz="1500" dirty="0">
+              <a:rPr lang="en-US" sz="1600" dirty="0">
                 <a:solidFill>
                   <a:srgbClr val="E6E6F0"/>
                 </a:solidFill>
@@ -16727,14 +16727,14 @@
               </a:rPr>
               <a:t>resource "aws_s3_bucket_versioning" "demo" {</a:t>
             </a:r>
-            <a:endParaRPr lang="en-US" sz="1500" dirty="0"/>
+            <a:endParaRPr lang="en-US" sz="1600" dirty="0"/>
           </a:p>
           <a:p>
             <a:pPr indent="0" marL="0">
               <a:buNone/>
             </a:pPr>
             <a:r>
-              <a:rPr lang="en-US" sz="1500" dirty="0">
+              <a:rPr lang="en-US" sz="1600" dirty="0">
                 <a:solidFill>
                   <a:srgbClr val="E6E6F0"/>
                 </a:solidFill>
@@ -16748,7 +16748,7 @@
               <a:buNone/>
             </a:pPr>
             <a:r>
-              <a:rPr lang="en-US" sz="1500" dirty="0">
+              <a:rPr lang="en-US" sz="1600" dirty="0">
                 <a:solidFill>
                   <a:srgbClr val="8FD694"/>
                 </a:solidFill>
@@ -16758,14 +16758,14 @@
               </a:rPr>
               <a:t># dipendenza</a:t>
             </a:r>
-            <a:endParaRPr lang="en-US" sz="1500" dirty="0"/>
+            <a:endParaRPr lang="en-US" sz="1600" dirty="0"/>
           </a:p>
           <a:p>
             <a:pPr indent="0" marL="0">
               <a:buNone/>
             </a:pPr>
             <a:r>
-              <a:rPr lang="en-US" sz="1500" dirty="0">
+              <a:rPr lang="en-US" sz="1600" dirty="0">
                 <a:solidFill>
                   <a:srgbClr val="E6E6F0"/>
                 </a:solidFill>
@@ -16775,14 +16775,14 @@
               </a:rPr>
               <a:t>  versioning_configuration {</a:t>
             </a:r>
-            <a:endParaRPr lang="en-US" sz="1500" dirty="0"/>
+            <a:endParaRPr lang="en-US" sz="1600" dirty="0"/>
           </a:p>
           <a:p>
             <a:pPr indent="0" marL="0">
               <a:buNone/>
             </a:pPr>
             <a:r>
-              <a:rPr lang="en-US" sz="1500" dirty="0">
+              <a:rPr lang="en-US" sz="1600" dirty="0">
                 <a:solidFill>
                   <a:srgbClr val="E6E6F0"/>
                 </a:solidFill>
@@ -16792,14 +16792,14 @@
               </a:rPr>
               <a:t>    status = "Enabled"</a:t>
             </a:r>
-            <a:endParaRPr lang="en-US" sz="1500" dirty="0"/>
+            <a:endParaRPr lang="en-US" sz="1600" dirty="0"/>
           </a:p>
           <a:p>
             <a:pPr indent="0" marL="0">
               <a:buNone/>
             </a:pPr>
             <a:r>
-              <a:rPr lang="en-US" sz="1500" dirty="0">
+              <a:rPr lang="en-US" sz="1600" dirty="0">
                 <a:solidFill>
                   <a:srgbClr val="E6E6F0"/>
                 </a:solidFill>
@@ -16809,14 +16809,14 @@
               </a:rPr>
               <a:t>  }</a:t>
             </a:r>
-            <a:endParaRPr lang="en-US" sz="1500" dirty="0"/>
+            <a:endParaRPr lang="en-US" sz="1600" dirty="0"/>
           </a:p>
           <a:p>
             <a:pPr indent="0" marL="0">
               <a:buNone/>
             </a:pPr>
             <a:r>
-              <a:rPr lang="en-US" sz="1500" dirty="0">
+              <a:rPr lang="en-US" sz="1600" dirty="0">
                 <a:solidFill>
                   <a:srgbClr val="E6E6F0"/>
                 </a:solidFill>
@@ -16826,7 +16826,7 @@
               </a:rPr>
               <a:t>}</a:t>
             </a:r>
-            <a:endParaRPr lang="en-US" sz="1500" dirty="0"/>
+            <a:endParaRPr lang="en-US" sz="1600" dirty="0"/>
           </a:p>
         </p:txBody>
       </p:sp>

</xml_diff>